<commit_message>
chore(preview): indice_DAX_40 outputs regeneres
</commit_message>
<xml_diff>
--- a/preview/indice_DAX_40/indice_DAX_40.pptx
+++ b/preview/indice_DAX_40/indice_DAX_40.pptx
@@ -19534,16 +19534,83 @@
           </a:p>
         </p:txBody>
       </p:sp>
-      <p:sp>
-        <p:nvSpPr>
-          <p:cNvPr id="15" name="Rectangle 14"/>
+      <p:pic>
+        <p:nvPicPr>
+          <p:cNvPr id="15" name="Picture 14" descr="image.png"/>
+          <p:cNvPicPr>
+            <a:picLocks noChangeAspect="1"/>
+          </p:cNvPicPr>
+          <p:nvPr/>
+        </p:nvPicPr>
+        <p:blipFill>
+          <a:blip r:embed="rId2"/>
+          <a:stretch>
+            <a:fillRect/>
+          </a:stretch>
+        </p:blipFill>
+        <p:spPr>
+          <a:xfrm>
+            <a:off x="324000" y="792000"/>
+            <a:ext cx="8496000" cy="2592000"/>
+          </a:xfrm>
+          <a:prstGeom prst="rect">
+            <a:avLst/>
+          </a:prstGeom>
+        </p:spPr>
+      </p:pic>
+      <p:sp>
+        <p:nvSpPr>
+          <p:cNvPr id="16" name="Rectangle 15"/>
           <p:cNvSpPr/>
           <p:nvPr/>
         </p:nvSpPr>
         <p:spPr>
           <a:xfrm>
-            <a:off x="0" y="0"/>
-            <a:ext cx="9144000" cy="503999"/>
+            <a:off x="324000" y="3491999"/>
+            <a:ext cx="8496000" cy="1314000"/>
+          </a:xfrm>
+          <a:prstGeom prst="rect">
+            <a:avLst/>
+          </a:prstGeom>
+          <a:solidFill>
+            <a:srgbClr val="F5F7FA"/>
+          </a:solidFill>
+          <a:ln>
+            <a:noFill/>
+          </a:ln>
+        </p:spPr>
+        <p:style>
+          <a:lnRef idx="1">
+            <a:schemeClr val="accent1"/>
+          </a:lnRef>
+          <a:fillRef idx="3">
+            <a:schemeClr val="accent1"/>
+          </a:fillRef>
+          <a:effectRef idx="2">
+            <a:schemeClr val="accent1"/>
+          </a:effectRef>
+          <a:fontRef idx="minor">
+            <a:schemeClr val="lt1"/>
+          </a:fontRef>
+        </p:style>
+        <p:txBody>
+          <a:bodyPr rtlCol="0" anchor="ctr"/>
+          <a:lstStyle/>
+          <a:p>
+            <a:pPr algn="ctr"/>
+          </a:p>
+        </p:txBody>
+      </p:sp>
+      <p:sp>
+        <p:nvSpPr>
+          <p:cNvPr id="17" name="Rectangle 16"/>
+          <p:cNvSpPr/>
+          <p:nvPr/>
+        </p:nvSpPr>
+        <p:spPr>
+          <a:xfrm>
+            <a:off x="324000" y="3491999"/>
+            <a:ext cx="43200" cy="1314000"/>
           </a:xfrm>
           <a:prstGeom prst="rect">
             <a:avLst/>
@@ -19579,14 +19646,14 @@
       </p:sp>
       <p:sp>
         <p:nvSpPr>
-          <p:cNvPr id="16" name="TextBox 15"/>
-          <p:cNvSpPr txBox="1"/>
-          <p:nvPr/>
-        </p:nvSpPr>
-        <p:spPr>
-          <a:xfrm>
-            <a:off x="324000" y="18000"/>
-            <a:ext cx="6876000" cy="468000"/>
+          <p:cNvPr id="18" name="TextBox 17"/>
+          <p:cNvSpPr txBox="1"/>
+          <p:nvPr/>
+        </p:nvSpPr>
+        <p:spPr>
+          <a:xfrm>
+            <a:off x="432000" y="3546000"/>
+            <a:ext cx="8208000" cy="216000"/>
           </a:xfrm>
           <a:prstGeom prst="rect">
             <a:avLst/>
@@ -19601,2166 +19668,60 @@
           <a:p>
             <a:pPr algn="l"/>
             <a:r>
-              <a:rPr sz="1300" b="1" i="0">
-                <a:solidFill>
-                  <a:srgbClr val="FFFFFF"/>
-                </a:solidFill>
-              </a:rPr>
-              <a:t>Performance des ETF Sectoriels — 52 Semaines</a:t>
-            </a:r>
-          </a:p>
-        </p:txBody>
-      </p:sp>
-      <p:sp>
-        <p:nvSpPr>
-          <p:cNvPr id="17" name="Rectangle 16"/>
+              <a:rPr sz="800" b="1" i="0">
+                <a:solidFill>
+                  <a:srgbClr val="1B3A6B"/>
+                </a:solidFill>
+              </a:rPr>
+              <a:t>Lecture — Performance DAX 40 sur 52 semaines</a:t>
+            </a:r>
+          </a:p>
+        </p:txBody>
+      </p:sp>
+      <p:sp>
+        <p:nvSpPr>
+          <p:cNvPr id="19" name="TextBox 18"/>
+          <p:cNvSpPr txBox="1"/>
+          <p:nvPr/>
+        </p:nvSpPr>
+        <p:spPr>
+          <a:xfrm>
+            <a:off x="432000" y="3780000"/>
+            <a:ext cx="8208000" cy="990000"/>
+          </a:xfrm>
+          <a:prstGeom prst="rect">
+            <a:avLst/>
+          </a:prstGeom>
+          <a:noFill/>
+        </p:spPr>
+        <p:txBody>
+          <a:bodyPr wrap="square">
+            <a:spAutoFit/>
+          </a:bodyPr>
+          <a:lstStyle/>
+          <a:p>
+            <a:pPr algn="l"/>
+            <a:r>
+              <a:rPr sz="750" b="0" i="0">
+                <a:solidFill>
+                  <a:srgbClr val="555555"/>
+                </a:solidFill>
+              </a:rPr>
+              <a:t>Performance DAX 40 sur 52 semaines : +3.7% (base 100, de 2025-03 a 2026-04). Cours actuel : 23 299 (YTD : -5.1%).  S&amp;P 500 : +17.8% sur la periode — sous-perf de -14.1pt vs S&amp;P 500.  Obligations (^TNX) : +4.6% sur la periode — correlation positive avec les equites.  Or (GC=F) : +54.1% — refuge actif sur la periode.  Note : ETF sectoriels SPDR (XLK, XLV...) disponibles pour le S&amp;P 500 uniquement. Pour les indices europeens, les equivalents iShares / Amundi ne sont pas encore integres.</a:t>
+            </a:r>
+          </a:p>
+        </p:txBody>
+      </p:sp>
+      <p:sp>
+        <p:nvSpPr>
+          <p:cNvPr id="20" name="Rectangle 19"/>
           <p:cNvSpPr/>
           <p:nvPr/>
         </p:nvSpPr>
         <p:spPr>
           <a:xfrm>
-            <a:off x="7848000" y="125999"/>
-            <a:ext cx="198000" cy="198000"/>
-          </a:xfrm>
-          <a:prstGeom prst="rect">
-            <a:avLst/>
-          </a:prstGeom>
-          <a:solidFill>
-            <a:srgbClr val="2A5298"/>
-          </a:solidFill>
-          <a:ln>
-            <a:noFill/>
-          </a:ln>
-        </p:spPr>
-        <p:style>
-          <a:lnRef idx="1">
-            <a:schemeClr val="accent1"/>
-          </a:lnRef>
-          <a:fillRef idx="3">
-            <a:schemeClr val="accent1"/>
-          </a:fillRef>
-          <a:effectRef idx="2">
-            <a:schemeClr val="accent1"/>
-          </a:effectRef>
-          <a:fontRef idx="minor">
-            <a:schemeClr val="lt1"/>
-          </a:fontRef>
-        </p:style>
-        <p:txBody>
-          <a:bodyPr rtlCol="0" anchor="ctr"/>
-          <a:lstStyle/>
-          <a:p>
-            <a:pPr algn="ctr"/>
-          </a:p>
-        </p:txBody>
-      </p:sp>
-      <p:sp>
-        <p:nvSpPr>
-          <p:cNvPr id="18" name="TextBox 17"/>
-          <p:cNvSpPr txBox="1"/>
-          <p:nvPr/>
-        </p:nvSpPr>
-        <p:spPr>
-          <a:xfrm>
-            <a:off x="7848000" y="125999"/>
-            <a:ext cx="198000" cy="198000"/>
-          </a:xfrm>
-          <a:prstGeom prst="rect">
-            <a:avLst/>
-          </a:prstGeom>
-          <a:noFill/>
-        </p:spPr>
-        <p:txBody>
-          <a:bodyPr wrap="square">
-            <a:spAutoFit/>
-          </a:bodyPr>
-          <a:lstStyle/>
-          <a:p>
-            <a:pPr algn="ctr"/>
-            <a:r>
-              <a:rPr sz="700" b="1" i="0">
-                <a:solidFill>
-                  <a:srgbClr val="AAAAAA"/>
-                </a:solidFill>
-              </a:rPr>
-              <a:t>1</a:t>
-            </a:r>
-          </a:p>
-        </p:txBody>
-      </p:sp>
-      <p:sp>
-        <p:nvSpPr>
-          <p:cNvPr id="19" name="Rectangle 18"/>
-          <p:cNvSpPr/>
-          <p:nvPr/>
-        </p:nvSpPr>
-        <p:spPr>
-          <a:xfrm>
-            <a:off x="8100000" y="125999"/>
-            <a:ext cx="198000" cy="198000"/>
-          </a:xfrm>
-          <a:prstGeom prst="rect">
-            <a:avLst/>
-          </a:prstGeom>
-          <a:solidFill>
-            <a:srgbClr val="2A5298"/>
-          </a:solidFill>
-          <a:ln>
-            <a:noFill/>
-          </a:ln>
-        </p:spPr>
-        <p:style>
-          <a:lnRef idx="1">
-            <a:schemeClr val="accent1"/>
-          </a:lnRef>
-          <a:fillRef idx="3">
-            <a:schemeClr val="accent1"/>
-          </a:fillRef>
-          <a:effectRef idx="2">
-            <a:schemeClr val="accent1"/>
-          </a:effectRef>
-          <a:fontRef idx="minor">
-            <a:schemeClr val="lt1"/>
-          </a:fontRef>
-        </p:style>
-        <p:txBody>
-          <a:bodyPr rtlCol="0" anchor="ctr"/>
-          <a:lstStyle/>
-          <a:p>
-            <a:pPr algn="ctr"/>
-          </a:p>
-        </p:txBody>
-      </p:sp>
-      <p:sp>
-        <p:nvSpPr>
-          <p:cNvPr id="20" name="TextBox 19"/>
-          <p:cNvSpPr txBox="1"/>
-          <p:nvPr/>
-        </p:nvSpPr>
-        <p:spPr>
-          <a:xfrm>
-            <a:off x="8100000" y="125999"/>
-            <a:ext cx="198000" cy="198000"/>
-          </a:xfrm>
-          <a:prstGeom prst="rect">
-            <a:avLst/>
-          </a:prstGeom>
-          <a:noFill/>
-        </p:spPr>
-        <p:txBody>
-          <a:bodyPr wrap="square">
-            <a:spAutoFit/>
-          </a:bodyPr>
-          <a:lstStyle/>
-          <a:p>
-            <a:pPr algn="ctr"/>
-            <a:r>
-              <a:rPr sz="700" b="1" i="0">
-                <a:solidFill>
-                  <a:srgbClr val="AAAAAA"/>
-                </a:solidFill>
-              </a:rPr>
-              <a:t>2</a:t>
-            </a:r>
-          </a:p>
-        </p:txBody>
-      </p:sp>
-      <p:sp>
-        <p:nvSpPr>
-          <p:cNvPr id="21" name="Rectangle 20"/>
-          <p:cNvSpPr/>
-          <p:nvPr/>
-        </p:nvSpPr>
-        <p:spPr>
-          <a:xfrm>
-            <a:off x="8352000" y="125999"/>
-            <a:ext cx="198000" cy="198000"/>
-          </a:xfrm>
-          <a:prstGeom prst="rect">
-            <a:avLst/>
-          </a:prstGeom>
-          <a:solidFill>
-            <a:srgbClr val="2A5298"/>
-          </a:solidFill>
-          <a:ln>
-            <a:noFill/>
-          </a:ln>
-        </p:spPr>
-        <p:style>
-          <a:lnRef idx="1">
-            <a:schemeClr val="accent1"/>
-          </a:lnRef>
-          <a:fillRef idx="3">
-            <a:schemeClr val="accent1"/>
-          </a:fillRef>
-          <a:effectRef idx="2">
-            <a:schemeClr val="accent1"/>
-          </a:effectRef>
-          <a:fontRef idx="minor">
-            <a:schemeClr val="lt1"/>
-          </a:fontRef>
-        </p:style>
-        <p:txBody>
-          <a:bodyPr rtlCol="0" anchor="ctr"/>
-          <a:lstStyle/>
-          <a:p>
-            <a:pPr algn="ctr"/>
-          </a:p>
-        </p:txBody>
-      </p:sp>
-      <p:sp>
-        <p:nvSpPr>
-          <p:cNvPr id="22" name="TextBox 21"/>
-          <p:cNvSpPr txBox="1"/>
-          <p:nvPr/>
-        </p:nvSpPr>
-        <p:spPr>
-          <a:xfrm>
-            <a:off x="8352000" y="125999"/>
-            <a:ext cx="198000" cy="198000"/>
-          </a:xfrm>
-          <a:prstGeom prst="rect">
-            <a:avLst/>
-          </a:prstGeom>
-          <a:noFill/>
-        </p:spPr>
-        <p:txBody>
-          <a:bodyPr wrap="square">
-            <a:spAutoFit/>
-          </a:bodyPr>
-          <a:lstStyle/>
-          <a:p>
-            <a:pPr algn="ctr"/>
-            <a:r>
-              <a:rPr sz="700" b="1" i="0">
-                <a:solidFill>
-                  <a:srgbClr val="AAAAAA"/>
-                </a:solidFill>
-              </a:rPr>
-              <a:t>3</a:t>
-            </a:r>
-          </a:p>
-        </p:txBody>
-      </p:sp>
-      <p:sp>
-        <p:nvSpPr>
-          <p:cNvPr id="23" name="Rectangle 22"/>
-          <p:cNvSpPr/>
-          <p:nvPr/>
-        </p:nvSpPr>
-        <p:spPr>
-          <a:xfrm>
-            <a:off x="8604000" y="125999"/>
-            <a:ext cx="198000" cy="198000"/>
-          </a:xfrm>
-          <a:prstGeom prst="rect">
-            <a:avLst/>
-          </a:prstGeom>
-          <a:solidFill>
-            <a:srgbClr val="2A5298"/>
-          </a:solidFill>
-          <a:ln>
-            <a:noFill/>
-          </a:ln>
-        </p:spPr>
-        <p:style>
-          <a:lnRef idx="1">
-            <a:schemeClr val="accent1"/>
-          </a:lnRef>
-          <a:fillRef idx="3">
-            <a:schemeClr val="accent1"/>
-          </a:fillRef>
-          <a:effectRef idx="2">
-            <a:schemeClr val="accent1"/>
-          </a:effectRef>
-          <a:fontRef idx="minor">
-            <a:schemeClr val="lt1"/>
-          </a:fontRef>
-        </p:style>
-        <p:txBody>
-          <a:bodyPr rtlCol="0" anchor="ctr"/>
-          <a:lstStyle/>
-          <a:p>
-            <a:pPr algn="ctr"/>
-          </a:p>
-        </p:txBody>
-      </p:sp>
-      <p:sp>
-        <p:nvSpPr>
-          <p:cNvPr id="24" name="TextBox 23"/>
-          <p:cNvSpPr txBox="1"/>
-          <p:nvPr/>
-        </p:nvSpPr>
-        <p:spPr>
-          <a:xfrm>
-            <a:off x="8604000" y="125999"/>
-            <a:ext cx="198000" cy="198000"/>
-          </a:xfrm>
-          <a:prstGeom prst="rect">
-            <a:avLst/>
-          </a:prstGeom>
-          <a:noFill/>
-        </p:spPr>
-        <p:txBody>
-          <a:bodyPr wrap="square">
-            <a:spAutoFit/>
-          </a:bodyPr>
-          <a:lstStyle/>
-          <a:p>
-            <a:pPr algn="ctr"/>
-            <a:r>
-              <a:rPr sz="700" b="1" i="0">
-                <a:solidFill>
-                  <a:srgbClr val="AAAAAA"/>
-                </a:solidFill>
-              </a:rPr>
-              <a:t>4</a:t>
-            </a:r>
-          </a:p>
-        </p:txBody>
-      </p:sp>
-      <p:sp>
-        <p:nvSpPr>
-          <p:cNvPr id="25" name="Rectangle 24"/>
-          <p:cNvSpPr/>
-          <p:nvPr/>
-        </p:nvSpPr>
-        <p:spPr>
-          <a:xfrm>
-            <a:off x="8856000" y="125999"/>
-            <a:ext cx="198000" cy="198000"/>
-          </a:xfrm>
-          <a:prstGeom prst="rect">
-            <a:avLst/>
-          </a:prstGeom>
-          <a:solidFill>
-            <a:srgbClr val="FFFFFF"/>
-          </a:solidFill>
-          <a:ln>
-            <a:noFill/>
-          </a:ln>
-        </p:spPr>
-        <p:style>
-          <a:lnRef idx="1">
-            <a:schemeClr val="accent1"/>
-          </a:lnRef>
-          <a:fillRef idx="3">
-            <a:schemeClr val="accent1"/>
-          </a:fillRef>
-          <a:effectRef idx="2">
-            <a:schemeClr val="accent1"/>
-          </a:effectRef>
-          <a:fontRef idx="minor">
-            <a:schemeClr val="lt1"/>
-          </a:fontRef>
-        </p:style>
-        <p:txBody>
-          <a:bodyPr rtlCol="0" anchor="ctr"/>
-          <a:lstStyle/>
-          <a:p>
-            <a:pPr algn="ctr"/>
-          </a:p>
-        </p:txBody>
-      </p:sp>
-      <p:sp>
-        <p:nvSpPr>
-          <p:cNvPr id="26" name="TextBox 25"/>
-          <p:cNvSpPr txBox="1"/>
-          <p:nvPr/>
-        </p:nvSpPr>
-        <p:spPr>
-          <a:xfrm>
-            <a:off x="8856000" y="125999"/>
-            <a:ext cx="198000" cy="198000"/>
-          </a:xfrm>
-          <a:prstGeom prst="rect">
-            <a:avLst/>
-          </a:prstGeom>
-          <a:noFill/>
-        </p:spPr>
-        <p:txBody>
-          <a:bodyPr wrap="square">
-            <a:spAutoFit/>
-          </a:bodyPr>
-          <a:lstStyle/>
-          <a:p>
-            <a:pPr algn="ctr"/>
-            <a:r>
-              <a:rPr sz="700" b="1" i="0">
-                <a:solidFill>
-                  <a:srgbClr val="1A1A1A"/>
-                </a:solidFill>
-              </a:rPr>
-              <a:t>5</a:t>
-            </a:r>
-          </a:p>
-        </p:txBody>
-      </p:sp>
-      <p:sp>
-        <p:nvSpPr>
-          <p:cNvPr id="27" name="TextBox 26"/>
-          <p:cNvSpPr txBox="1"/>
-          <p:nvPr/>
-        </p:nvSpPr>
-        <p:spPr>
-          <a:xfrm>
-            <a:off x="324000" y="576000"/>
-            <a:ext cx="8496000" cy="216000"/>
-          </a:xfrm>
-          <a:prstGeom prst="rect">
-            <a:avLst/>
-          </a:prstGeom>
-          <a:noFill/>
-        </p:spPr>
-        <p:txBody>
-          <a:bodyPr wrap="square">
-            <a:spAutoFit/>
-          </a:bodyPr>
-          <a:lstStyle/>
-          <a:p>
-            <a:pPr algn="l"/>
-            <a:r>
-              <a:rPr sz="800" b="0" i="0">
-                <a:solidFill>
-                  <a:srgbClr val="555555"/>
-                </a:solidFill>
-              </a:rPr>
-              <a:t>DAX 40  ·  ETF sectoriels SPDR/iShares  ·  Donnees yfinance</a:t>
-            </a:r>
-          </a:p>
-        </p:txBody>
-      </p:sp>
-      <p:sp>
-        <p:nvSpPr>
-          <p:cNvPr id="28" name="TextBox 27"/>
-          <p:cNvSpPr txBox="1"/>
-          <p:nvPr/>
-        </p:nvSpPr>
-        <p:spPr>
-          <a:xfrm>
-            <a:off x="324000" y="756000"/>
-            <a:ext cx="8496000" cy="198000"/>
-          </a:xfrm>
-          <a:prstGeom prst="rect">
-            <a:avLst/>
-          </a:prstGeom>
-          <a:noFill/>
-        </p:spPr>
-        <p:txBody>
-          <a:bodyPr wrap="square">
-            <a:spAutoFit/>
-          </a:bodyPr>
-          <a:lstStyle/>
-          <a:p>
-            <a:pPr algn="l"/>
-            <a:r>
-              <a:rPr sz="850" b="1" i="0">
-                <a:solidFill>
-                  <a:srgbClr val="1B3A6B"/>
-                </a:solidFill>
-              </a:rPr>
-              <a:t>Scores sectoriels FinSight — synthese allocataire</a:t>
-            </a:r>
-          </a:p>
-        </p:txBody>
-      </p:sp>
-      <p:graphicFrame>
-        <p:nvGraphicFramePr>
-          <p:cNvPr id="29" name="Table 28"/>
-          <p:cNvGraphicFramePr>
-            <a:graphicFrameLocks noGrp="1"/>
-          </p:cNvGraphicFramePr>
-          <p:nvPr/>
-        </p:nvGraphicFramePr>
-        <p:xfrm>
-          <a:off x="324000" y="990000"/>
-          <a:ext cx="8495995" cy="2808000"/>
-        </p:xfrm>
-        <a:graphic>
-          <a:graphicData uri="http://schemas.openxmlformats.org/drawingml/2006/table">
-            <a:tbl>
-              <a:tblPr firstRow="1" bandRow="1">
-                <a:tableStyleId>{5C22544A-7EE6-4342-B048-85BDC9FD1C3A}</a:tableStyleId>
-              </a:tblPr>
-              <a:tblGrid>
-                <a:gridCol w="545197"/>
-                <a:gridCol w="2271657"/>
-                <a:gridCol w="681497"/>
-                <a:gridCol w="1590160"/>
-                <a:gridCol w="1135828"/>
-                <a:gridCol w="1135828"/>
-                <a:gridCol w="1135828"/>
-              </a:tblGrid>
-              <a:tr h="255272">
-                <a:tc>
-                  <a:txBody>
-                    <a:bodyPr/>
-                    <a:lstStyle/>
-                    <a:p>
-                      <a:pPr algn="ctr"/>
-                      <a:r>
-                        <a:rPr sz="800" b="1">
-                          <a:solidFill>
-                            <a:srgbClr val="FFFFFF"/>
-                          </a:solidFill>
-                        </a:rPr>
-                        <a:t>Rang</a:t>
-                      </a:r>
-                    </a:p>
-                  </a:txBody>
-                  <a:tcPr>
-                    <a:solidFill>
-                      <a:srgbClr val="1B3A6B"/>
-                    </a:solidFill>
-                  </a:tcPr>
-                </a:tc>
-                <a:tc>
-                  <a:txBody>
-                    <a:bodyPr/>
-                    <a:lstStyle/>
-                    <a:p>
-                      <a:pPr algn="ctr"/>
-                      <a:r>
-                        <a:rPr sz="800" b="1">
-                          <a:solidFill>
-                            <a:srgbClr val="FFFFFF"/>
-                          </a:solidFill>
-                        </a:rPr>
-                        <a:t>Secteur</a:t>
-                      </a:r>
-                    </a:p>
-                  </a:txBody>
-                  <a:tcPr>
-                    <a:solidFill>
-                      <a:srgbClr val="1B3A6B"/>
-                    </a:solidFill>
-                  </a:tcPr>
-                </a:tc>
-                <a:tc>
-                  <a:txBody>
-                    <a:bodyPr/>
-                    <a:lstStyle/>
-                    <a:p>
-                      <a:pPr algn="ctr"/>
-                      <a:r>
-                        <a:rPr sz="800" b="1">
-                          <a:solidFill>
-                            <a:srgbClr val="FFFFFF"/>
-                          </a:solidFill>
-                        </a:rPr>
-                        <a:t>Score</a:t>
-                      </a:r>
-                    </a:p>
-                  </a:txBody>
-                  <a:tcPr>
-                    <a:solidFill>
-                      <a:srgbClr val="1B3A6B"/>
-                    </a:solidFill>
-                  </a:tcPr>
-                </a:tc>
-                <a:tc>
-                  <a:txBody>
-                    <a:bodyPr/>
-                    <a:lstStyle/>
-                    <a:p>
-                      <a:pPr algn="ctr"/>
-                      <a:r>
-                        <a:rPr sz="800" b="1">
-                          <a:solidFill>
-                            <a:srgbClr val="FFFFFF"/>
-                          </a:solidFill>
-                        </a:rPr>
-                        <a:t>Signal</a:t>
-                      </a:r>
-                    </a:p>
-                  </a:txBody>
-                  <a:tcPr>
-                    <a:solidFill>
-                      <a:srgbClr val="1B3A6B"/>
-                    </a:solidFill>
-                  </a:tcPr>
-                </a:tc>
-                <a:tc>
-                  <a:txBody>
-                    <a:bodyPr/>
-                    <a:lstStyle/>
-                    <a:p>
-                      <a:pPr algn="ctr"/>
-                      <a:r>
-                        <a:rPr sz="800" b="1">
-                          <a:solidFill>
-                            <a:srgbClr val="FFFFFF"/>
-                          </a:solidFill>
-                        </a:rPr>
-                        <a:t>EV/EBITDA</a:t>
-                      </a:r>
-                    </a:p>
-                  </a:txBody>
-                  <a:tcPr>
-                    <a:solidFill>
-                      <a:srgbClr val="1B3A6B"/>
-                    </a:solidFill>
-                  </a:tcPr>
-                </a:tc>
-                <a:tc>
-                  <a:txBody>
-                    <a:bodyPr/>
-                    <a:lstStyle/>
-                    <a:p>
-                      <a:pPr algn="ctr"/>
-                      <a:r>
-                        <a:rPr sz="800" b="1">
-                          <a:solidFill>
-                            <a:srgbClr val="FFFFFF"/>
-                          </a:solidFill>
-                        </a:rPr>
-                        <a:t>Mg.EBITDA</a:t>
-                      </a:r>
-                    </a:p>
-                  </a:txBody>
-                  <a:tcPr>
-                    <a:solidFill>
-                      <a:srgbClr val="1B3A6B"/>
-                    </a:solidFill>
-                  </a:tcPr>
-                </a:tc>
-                <a:tc>
-                  <a:txBody>
-                    <a:bodyPr/>
-                    <a:lstStyle/>
-                    <a:p>
-                      <a:pPr algn="ctr"/>
-                      <a:r>
-                        <a:rPr sz="800" b="1">
-                          <a:solidFill>
-                            <a:srgbClr val="FFFFFF"/>
-                          </a:solidFill>
-                        </a:rPr>
-                        <a:t>Croiss.</a:t>
-                      </a:r>
-                    </a:p>
-                  </a:txBody>
-                  <a:tcPr>
-                    <a:solidFill>
-                      <a:srgbClr val="1B3A6B"/>
-                    </a:solidFill>
-                  </a:tcPr>
-                </a:tc>
-              </a:tr>
-              <a:tr h="255272">
-                <a:tc>
-                  <a:txBody>
-                    <a:bodyPr/>
-                    <a:lstStyle/>
-                    <a:p>
-                      <a:pPr algn="ctr"/>
-                      <a:r>
-                        <a:rPr sz="800" b="0">
-                          <a:solidFill>
-                            <a:srgbClr val="1A1A1A"/>
-                          </a:solidFill>
-                        </a:rPr>
-                        <a:t>1</a:t>
-                      </a:r>
-                    </a:p>
-                  </a:txBody>
-                  <a:tcPr>
-                    <a:noFill/>
-                  </a:tcPr>
-                </a:tc>
-                <a:tc>
-                  <a:txBody>
-                    <a:bodyPr/>
-                    <a:lstStyle/>
-                    <a:p>
-                      <a:pPr algn="ctr"/>
-                      <a:r>
-                        <a:rPr sz="800" b="0">
-                          <a:solidFill>
-                            <a:srgbClr val="1A1A1A"/>
-                          </a:solidFill>
-                        </a:rPr>
-                        <a:t>Utilities</a:t>
-                      </a:r>
-                    </a:p>
-                  </a:txBody>
-                  <a:tcPr>
-                    <a:noFill/>
-                  </a:tcPr>
-                </a:tc>
-                <a:tc>
-                  <a:txBody>
-                    <a:bodyPr/>
-                    <a:lstStyle/>
-                    <a:p>
-                      <a:pPr algn="ctr"/>
-                      <a:r>
-                        <a:rPr sz="800" b="0">
-                          <a:solidFill>
-                            <a:srgbClr val="1A1A1A"/>
-                          </a:solidFill>
-                        </a:rPr>
-                        <a:t>85</a:t>
-                      </a:r>
-                    </a:p>
-                  </a:txBody>
-                  <a:tcPr>
-                    <a:noFill/>
-                  </a:tcPr>
-                </a:tc>
-                <a:tc>
-                  <a:txBody>
-                    <a:bodyPr/>
-                    <a:lstStyle/>
-                    <a:p>
-                      <a:pPr algn="ctr"/>
-                      <a:r>
-                        <a:rPr sz="800" b="0">
-                          <a:solidFill>
-                            <a:srgbClr val="1A7A4A"/>
-                          </a:solidFill>
-                        </a:rPr>
-                        <a:t>Surponderer</a:t>
-                      </a:r>
-                    </a:p>
-                  </a:txBody>
-                  <a:tcPr>
-                    <a:solidFill>
-                      <a:srgbClr val="E8F5EE"/>
-                    </a:solidFill>
-                  </a:tcPr>
-                </a:tc>
-                <a:tc>
-                  <a:txBody>
-                    <a:bodyPr/>
-                    <a:lstStyle/>
-                    <a:p>
-                      <a:pPr algn="ctr"/>
-                      <a:r>
-                        <a:rPr sz="800" b="0">
-                          <a:solidFill>
-                            <a:srgbClr val="1A1A1A"/>
-                          </a:solidFill>
-                        </a:rPr>
-                        <a:t>19.0x</a:t>
-                      </a:r>
-                    </a:p>
-                  </a:txBody>
-                  <a:tcPr>
-                    <a:noFill/>
-                  </a:tcPr>
-                </a:tc>
-                <a:tc>
-                  <a:txBody>
-                    <a:bodyPr/>
-                    <a:lstStyle/>
-                    <a:p>
-                      <a:pPr algn="ctr"/>
-                      <a:r>
-                        <a:rPr sz="800" b="0">
-                          <a:solidFill>
-                            <a:srgbClr val="1A1A1A"/>
-                          </a:solidFill>
-                        </a:rPr>
-                        <a:t>10.4%</a:t>
-                      </a:r>
-                    </a:p>
-                  </a:txBody>
-                  <a:tcPr>
-                    <a:noFill/>
-                  </a:tcPr>
-                </a:tc>
-                <a:tc>
-                  <a:txBody>
-                    <a:bodyPr/>
-                    <a:lstStyle/>
-                    <a:p>
-                      <a:pPr algn="ctr"/>
-                      <a:r>
-                        <a:rPr sz="800" b="0">
-                          <a:solidFill>
-                            <a:srgbClr val="1A1A1A"/>
-                          </a:solidFill>
-                        </a:rPr>
-                        <a:t>-26.3%</a:t>
-                      </a:r>
-                    </a:p>
-                  </a:txBody>
-                  <a:tcPr>
-                    <a:noFill/>
-                  </a:tcPr>
-                </a:tc>
-              </a:tr>
-              <a:tr h="255272">
-                <a:tc>
-                  <a:txBody>
-                    <a:bodyPr/>
-                    <a:lstStyle/>
-                    <a:p>
-                      <a:pPr algn="ctr"/>
-                      <a:r>
-                        <a:rPr sz="800" b="0">
-                          <a:solidFill>
-                            <a:srgbClr val="1A1A1A"/>
-                          </a:solidFill>
-                        </a:rPr>
-                        <a:t>2</a:t>
-                      </a:r>
-                    </a:p>
-                  </a:txBody>
-                  <a:tcPr>
-                    <a:solidFill>
-                      <a:srgbClr val="F5F7FA"/>
-                    </a:solidFill>
-                  </a:tcPr>
-                </a:tc>
-                <a:tc>
-                  <a:txBody>
-                    <a:bodyPr/>
-                    <a:lstStyle/>
-                    <a:p>
-                      <a:pPr algn="ctr"/>
-                      <a:r>
-                        <a:rPr sz="800" b="0">
-                          <a:solidFill>
-                            <a:srgbClr val="1A1A1A"/>
-                          </a:solidFill>
-                        </a:rPr>
-                        <a:t>Industrials</a:t>
-                      </a:r>
-                    </a:p>
-                  </a:txBody>
-                  <a:tcPr>
-                    <a:solidFill>
-                      <a:srgbClr val="F5F7FA"/>
-                    </a:solidFill>
-                  </a:tcPr>
-                </a:tc>
-                <a:tc>
-                  <a:txBody>
-                    <a:bodyPr/>
-                    <a:lstStyle/>
-                    <a:p>
-                      <a:pPr algn="ctr"/>
-                      <a:r>
-                        <a:rPr sz="800" b="0">
-                          <a:solidFill>
-                            <a:srgbClr val="1A1A1A"/>
-                          </a:solidFill>
-                        </a:rPr>
-                        <a:t>67</a:t>
-                      </a:r>
-                    </a:p>
-                  </a:txBody>
-                  <a:tcPr>
-                    <a:solidFill>
-                      <a:srgbClr val="F5F7FA"/>
-                    </a:solidFill>
-                  </a:tcPr>
-                </a:tc>
-                <a:tc>
-                  <a:txBody>
-                    <a:bodyPr/>
-                    <a:lstStyle/>
-                    <a:p>
-                      <a:pPr algn="ctr"/>
-                      <a:r>
-                        <a:rPr sz="800" b="0">
-                          <a:solidFill>
-                            <a:srgbClr val="1A7A4A"/>
-                          </a:solidFill>
-                        </a:rPr>
-                        <a:t>Surponderer</a:t>
-                      </a:r>
-                    </a:p>
-                  </a:txBody>
-                  <a:tcPr>
-                    <a:solidFill>
-                      <a:srgbClr val="E8F5EE"/>
-                    </a:solidFill>
-                  </a:tcPr>
-                </a:tc>
-                <a:tc>
-                  <a:txBody>
-                    <a:bodyPr/>
-                    <a:lstStyle/>
-                    <a:p>
-                      <a:pPr algn="ctr"/>
-                      <a:r>
-                        <a:rPr sz="800" b="0">
-                          <a:solidFill>
-                            <a:srgbClr val="1A1A1A"/>
-                          </a:solidFill>
-                        </a:rPr>
-                        <a:t>14.3x</a:t>
-                      </a:r>
-                    </a:p>
-                  </a:txBody>
-                  <a:tcPr>
-                    <a:solidFill>
-                      <a:srgbClr val="F5F7FA"/>
-                    </a:solidFill>
-                  </a:tcPr>
-                </a:tc>
-                <a:tc>
-                  <a:txBody>
-                    <a:bodyPr/>
-                    <a:lstStyle/>
-                    <a:p>
-                      <a:pPr algn="ctr"/>
-                      <a:r>
-                        <a:rPr sz="800" b="0">
-                          <a:solidFill>
-                            <a:srgbClr val="1A1A1A"/>
-                          </a:solidFill>
-                        </a:rPr>
-                        <a:t>11.8%</a:t>
-                      </a:r>
-                    </a:p>
-                  </a:txBody>
-                  <a:tcPr>
-                    <a:solidFill>
-                      <a:srgbClr val="F5F7FA"/>
-                    </a:solidFill>
-                  </a:tcPr>
-                </a:tc>
-                <a:tc>
-                  <a:txBody>
-                    <a:bodyPr/>
-                    <a:lstStyle/>
-                    <a:p>
-                      <a:pPr algn="ctr"/>
-                      <a:r>
-                        <a:rPr sz="800" b="0">
-                          <a:solidFill>
-                            <a:srgbClr val="1A1A1A"/>
-                          </a:solidFill>
-                        </a:rPr>
-                        <a:t>+5.5%</a:t>
-                      </a:r>
-                    </a:p>
-                  </a:txBody>
-                  <a:tcPr>
-                    <a:solidFill>
-                      <a:srgbClr val="F5F7FA"/>
-                    </a:solidFill>
-                  </a:tcPr>
-                </a:tc>
-              </a:tr>
-              <a:tr h="255272">
-                <a:tc>
-                  <a:txBody>
-                    <a:bodyPr/>
-                    <a:lstStyle/>
-                    <a:p>
-                      <a:pPr algn="ctr"/>
-                      <a:r>
-                        <a:rPr sz="800" b="0">
-                          <a:solidFill>
-                            <a:srgbClr val="1A1A1A"/>
-                          </a:solidFill>
-                        </a:rPr>
-                        <a:t>3</a:t>
-                      </a:r>
-                    </a:p>
-                  </a:txBody>
-                  <a:tcPr>
-                    <a:noFill/>
-                  </a:tcPr>
-                </a:tc>
-                <a:tc>
-                  <a:txBody>
-                    <a:bodyPr/>
-                    <a:lstStyle/>
-                    <a:p>
-                      <a:pPr algn="ctr"/>
-                      <a:r>
-                        <a:rPr sz="800" b="0">
-                          <a:solidFill>
-                            <a:srgbClr val="1A1A1A"/>
-                          </a:solidFill>
-                        </a:rPr>
-                        <a:t>Technology</a:t>
-                      </a:r>
-                    </a:p>
-                  </a:txBody>
-                  <a:tcPr>
-                    <a:noFill/>
-                  </a:tcPr>
-                </a:tc>
-                <a:tc>
-                  <a:txBody>
-                    <a:bodyPr/>
-                    <a:lstStyle/>
-                    <a:p>
-                      <a:pPr algn="ctr"/>
-                      <a:r>
-                        <a:rPr sz="800" b="0">
-                          <a:solidFill>
-                            <a:srgbClr val="1A1A1A"/>
-                          </a:solidFill>
-                        </a:rPr>
-                        <a:t>55</a:t>
-                      </a:r>
-                    </a:p>
-                  </a:txBody>
-                  <a:tcPr>
-                    <a:noFill/>
-                  </a:tcPr>
-                </a:tc>
-                <a:tc>
-                  <a:txBody>
-                    <a:bodyPr/>
-                    <a:lstStyle/>
-                    <a:p>
-                      <a:pPr algn="ctr"/>
-                      <a:r>
-                        <a:rPr sz="800" b="0">
-                          <a:solidFill>
-                            <a:srgbClr val="B06000"/>
-                          </a:solidFill>
-                        </a:rPr>
-                        <a:t>Neutre</a:t>
-                      </a:r>
-                    </a:p>
-                  </a:txBody>
-                  <a:tcPr>
-                    <a:solidFill>
-                      <a:srgbClr val="FDF3E5"/>
-                    </a:solidFill>
-                  </a:tcPr>
-                </a:tc>
-                <a:tc>
-                  <a:txBody>
-                    <a:bodyPr/>
-                    <a:lstStyle/>
-                    <a:p>
-                      <a:pPr algn="ctr"/>
-                      <a:r>
-                        <a:rPr sz="800" b="0">
-                          <a:solidFill>
-                            <a:srgbClr val="1A1A1A"/>
-                          </a:solidFill>
-                        </a:rPr>
-                        <a:t>14.8x</a:t>
-                      </a:r>
-                    </a:p>
-                  </a:txBody>
-                  <a:tcPr>
-                    <a:noFill/>
-                  </a:tcPr>
-                </a:tc>
-                <a:tc>
-                  <a:txBody>
-                    <a:bodyPr/>
-                    <a:lstStyle/>
-                    <a:p>
-                      <a:pPr algn="ctr"/>
-                      <a:r>
-                        <a:rPr sz="800" b="0">
-                          <a:solidFill>
-                            <a:srgbClr val="1A1A1A"/>
-                          </a:solidFill>
-                        </a:rPr>
-                        <a:t>28.9%</a:t>
-                      </a:r>
-                    </a:p>
-                  </a:txBody>
-                  <a:tcPr>
-                    <a:noFill/>
-                  </a:tcPr>
-                </a:tc>
-                <a:tc>
-                  <a:txBody>
-                    <a:bodyPr/>
-                    <a:lstStyle/>
-                    <a:p>
-                      <a:pPr algn="ctr"/>
-                      <a:r>
-                        <a:rPr sz="800" b="0">
-                          <a:solidFill>
-                            <a:srgbClr val="1A1A1A"/>
-                          </a:solidFill>
-                        </a:rPr>
-                        <a:t>+5.2%</a:t>
-                      </a:r>
-                    </a:p>
-                  </a:txBody>
-                  <a:tcPr>
-                    <a:noFill/>
-                  </a:tcPr>
-                </a:tc>
-              </a:tr>
-              <a:tr h="255272">
-                <a:tc>
-                  <a:txBody>
-                    <a:bodyPr/>
-                    <a:lstStyle/>
-                    <a:p>
-                      <a:pPr algn="ctr"/>
-                      <a:r>
-                        <a:rPr sz="800" b="0">
-                          <a:solidFill>
-                            <a:srgbClr val="1A1A1A"/>
-                          </a:solidFill>
-                        </a:rPr>
-                        <a:t>4</a:t>
-                      </a:r>
-                    </a:p>
-                  </a:txBody>
-                  <a:tcPr>
-                    <a:solidFill>
-                      <a:srgbClr val="F5F7FA"/>
-                    </a:solidFill>
-                  </a:tcPr>
-                </a:tc>
-                <a:tc>
-                  <a:txBody>
-                    <a:bodyPr/>
-                    <a:lstStyle/>
-                    <a:p>
-                      <a:pPr algn="ctr"/>
-                      <a:r>
-                        <a:rPr sz="800" b="0">
-                          <a:solidFill>
-                            <a:srgbClr val="1A1A1A"/>
-                          </a:solidFill>
-                        </a:rPr>
-                        <a:t>Health Care</a:t>
-                      </a:r>
-                    </a:p>
-                  </a:txBody>
-                  <a:tcPr>
-                    <a:solidFill>
-                      <a:srgbClr val="F5F7FA"/>
-                    </a:solidFill>
-                  </a:tcPr>
-                </a:tc>
-                <a:tc>
-                  <a:txBody>
-                    <a:bodyPr/>
-                    <a:lstStyle/>
-                    <a:p>
-                      <a:pPr algn="ctr"/>
-                      <a:r>
-                        <a:rPr sz="800" b="0">
-                          <a:solidFill>
-                            <a:srgbClr val="1A1A1A"/>
-                          </a:solidFill>
-                        </a:rPr>
-                        <a:t>51</a:t>
-                      </a:r>
-                    </a:p>
-                  </a:txBody>
-                  <a:tcPr>
-                    <a:solidFill>
-                      <a:srgbClr val="F5F7FA"/>
-                    </a:solidFill>
-                  </a:tcPr>
-                </a:tc>
-                <a:tc>
-                  <a:txBody>
-                    <a:bodyPr/>
-                    <a:lstStyle/>
-                    <a:p>
-                      <a:pPr algn="ctr"/>
-                      <a:r>
-                        <a:rPr sz="800" b="0">
-                          <a:solidFill>
-                            <a:srgbClr val="B06000"/>
-                          </a:solidFill>
-                        </a:rPr>
-                        <a:t>Neutre</a:t>
-                      </a:r>
-                    </a:p>
-                  </a:txBody>
-                  <a:tcPr>
-                    <a:solidFill>
-                      <a:srgbClr val="FDF3E5"/>
-                    </a:solidFill>
-                  </a:tcPr>
-                </a:tc>
-                <a:tc>
-                  <a:txBody>
-                    <a:bodyPr/>
-                    <a:lstStyle/>
-                    <a:p>
-                      <a:pPr algn="ctr"/>
-                      <a:r>
-                        <a:rPr sz="800" b="0">
-                          <a:solidFill>
-                            <a:srgbClr val="1A1A1A"/>
-                          </a:solidFill>
-                        </a:rPr>
-                        <a:t>11.3x</a:t>
-                      </a:r>
-                    </a:p>
-                  </a:txBody>
-                  <a:tcPr>
-                    <a:solidFill>
-                      <a:srgbClr val="F5F7FA"/>
-                    </a:solidFill>
-                  </a:tcPr>
-                </a:tc>
-                <a:tc>
-                  <a:txBody>
-                    <a:bodyPr/>
-                    <a:lstStyle/>
-                    <a:p>
-                      <a:pPr algn="ctr"/>
-                      <a:r>
-                        <a:rPr sz="800" b="0">
-                          <a:solidFill>
-                            <a:srgbClr val="1A1A1A"/>
-                          </a:solidFill>
-                        </a:rPr>
-                        <a:t>22.8%</a:t>
-                      </a:r>
-                    </a:p>
-                  </a:txBody>
-                  <a:tcPr>
-                    <a:solidFill>
-                      <a:srgbClr val="F5F7FA"/>
-                    </a:solidFill>
-                  </a:tcPr>
-                </a:tc>
-                <a:tc>
-                  <a:txBody>
-                    <a:bodyPr/>
-                    <a:lstStyle/>
-                    <a:p>
-                      <a:pPr algn="ctr"/>
-                      <a:r>
-                        <a:rPr sz="800" b="0">
-                          <a:solidFill>
-                            <a:srgbClr val="1A1A1A"/>
-                          </a:solidFill>
-                        </a:rPr>
-                        <a:t>+0.7%</a:t>
-                      </a:r>
-                    </a:p>
-                  </a:txBody>
-                  <a:tcPr>
-                    <a:solidFill>
-                      <a:srgbClr val="F5F7FA"/>
-                    </a:solidFill>
-                  </a:tcPr>
-                </a:tc>
-              </a:tr>
-              <a:tr h="255272">
-                <a:tc>
-                  <a:txBody>
-                    <a:bodyPr/>
-                    <a:lstStyle/>
-                    <a:p>
-                      <a:pPr algn="ctr"/>
-                      <a:r>
-                        <a:rPr sz="800" b="0">
-                          <a:solidFill>
-                            <a:srgbClr val="1A1A1A"/>
-                          </a:solidFill>
-                        </a:rPr>
-                        <a:t>5</a:t>
-                      </a:r>
-                    </a:p>
-                  </a:txBody>
-                  <a:tcPr>
-                    <a:noFill/>
-                  </a:tcPr>
-                </a:tc>
-                <a:tc>
-                  <a:txBody>
-                    <a:bodyPr/>
-                    <a:lstStyle/>
-                    <a:p>
-                      <a:pPr algn="ctr"/>
-                      <a:r>
-                        <a:rPr sz="800" b="0">
-                          <a:solidFill>
-                            <a:srgbClr val="1A1A1A"/>
-                          </a:solidFill>
-                        </a:rPr>
-                        <a:t>Financials</a:t>
-                      </a:r>
-                    </a:p>
-                  </a:txBody>
-                  <a:tcPr>
-                    <a:noFill/>
-                  </a:tcPr>
-                </a:tc>
-                <a:tc>
-                  <a:txBody>
-                    <a:bodyPr/>
-                    <a:lstStyle/>
-                    <a:p>
-                      <a:pPr algn="ctr"/>
-                      <a:r>
-                        <a:rPr sz="800" b="0">
-                          <a:solidFill>
-                            <a:srgbClr val="1A1A1A"/>
-                          </a:solidFill>
-                        </a:rPr>
-                        <a:t>50</a:t>
-                      </a:r>
-                    </a:p>
-                  </a:txBody>
-                  <a:tcPr>
-                    <a:noFill/>
-                  </a:tcPr>
-                </a:tc>
-                <a:tc>
-                  <a:txBody>
-                    <a:bodyPr/>
-                    <a:lstStyle/>
-                    <a:p>
-                      <a:pPr algn="ctr"/>
-                      <a:r>
-                        <a:rPr sz="800" b="0">
-                          <a:solidFill>
-                            <a:srgbClr val="B06000"/>
-                          </a:solidFill>
-                        </a:rPr>
-                        <a:t>Neutre</a:t>
-                      </a:r>
-                    </a:p>
-                  </a:txBody>
-                  <a:tcPr>
-                    <a:solidFill>
-                      <a:srgbClr val="FDF3E5"/>
-                    </a:solidFill>
-                  </a:tcPr>
-                </a:tc>
-                <a:tc>
-                  <a:txBody>
-                    <a:bodyPr/>
-                    <a:lstStyle/>
-                    <a:p>
-                      <a:pPr algn="ctr"/>
-                      <a:r>
-                        <a:rPr sz="800" b="0">
-                          <a:solidFill>
-                            <a:srgbClr val="1A1A1A"/>
-                          </a:solidFill>
-                        </a:rPr>
-                        <a:t>5.4x</a:t>
-                      </a:r>
-                    </a:p>
-                  </a:txBody>
-                  <a:tcPr>
-                    <a:noFill/>
-                  </a:tcPr>
-                </a:tc>
-                <a:tc>
-                  <a:txBody>
-                    <a:bodyPr/>
-                    <a:lstStyle/>
-                    <a:p>
-                      <a:pPr algn="ctr"/>
-                      <a:r>
-                        <a:rPr sz="800" b="0">
-                          <a:solidFill>
-                            <a:srgbClr val="1A1A1A"/>
-                          </a:solidFill>
-                        </a:rPr>
-                        <a:t>16.1%</a:t>
-                      </a:r>
-                    </a:p>
-                  </a:txBody>
-                  <a:tcPr>
-                    <a:noFill/>
-                  </a:tcPr>
-                </a:tc>
-                <a:tc>
-                  <a:txBody>
-                    <a:bodyPr/>
-                    <a:lstStyle/>
-                    <a:p>
-                      <a:pPr algn="ctr"/>
-                      <a:r>
-                        <a:rPr sz="800" b="0">
-                          <a:solidFill>
-                            <a:srgbClr val="1A1A1A"/>
-                          </a:solidFill>
-                        </a:rPr>
-                        <a:t>+0.3%</a:t>
-                      </a:r>
-                    </a:p>
-                  </a:txBody>
-                  <a:tcPr>
-                    <a:noFill/>
-                  </a:tcPr>
-                </a:tc>
-              </a:tr>
-              <a:tr h="255272">
-                <a:tc>
-                  <a:txBody>
-                    <a:bodyPr/>
-                    <a:lstStyle/>
-                    <a:p>
-                      <a:pPr algn="ctr"/>
-                      <a:r>
-                        <a:rPr sz="800" b="0">
-                          <a:solidFill>
-                            <a:srgbClr val="1A1A1A"/>
-                          </a:solidFill>
-                        </a:rPr>
-                        <a:t>6</a:t>
-                      </a:r>
-                    </a:p>
-                  </a:txBody>
-                  <a:tcPr>
-                    <a:solidFill>
-                      <a:srgbClr val="F5F7FA"/>
-                    </a:solidFill>
-                  </a:tcPr>
-                </a:tc>
-                <a:tc>
-                  <a:txBody>
-                    <a:bodyPr/>
-                    <a:lstStyle/>
-                    <a:p>
-                      <a:pPr algn="ctr"/>
-                      <a:r>
-                        <a:rPr sz="800" b="0">
-                          <a:solidFill>
-                            <a:srgbClr val="1A1A1A"/>
-                          </a:solidFill>
-                        </a:rPr>
-                        <a:t>Materials</a:t>
-                      </a:r>
-                    </a:p>
-                  </a:txBody>
-                  <a:tcPr>
-                    <a:solidFill>
-                      <a:srgbClr val="F5F7FA"/>
-                    </a:solidFill>
-                  </a:tcPr>
-                </a:tc>
-                <a:tc>
-                  <a:txBody>
-                    <a:bodyPr/>
-                    <a:lstStyle/>
-                    <a:p>
-                      <a:pPr algn="ctr"/>
-                      <a:r>
-                        <a:rPr sz="800" b="0">
-                          <a:solidFill>
-                            <a:srgbClr val="1A1A1A"/>
-                          </a:solidFill>
-                        </a:rPr>
-                        <a:t>45</a:t>
-                      </a:r>
-                    </a:p>
-                  </a:txBody>
-                  <a:tcPr>
-                    <a:solidFill>
-                      <a:srgbClr val="F5F7FA"/>
-                    </a:solidFill>
-                  </a:tcPr>
-                </a:tc>
-                <a:tc>
-                  <a:txBody>
-                    <a:bodyPr/>
-                    <a:lstStyle/>
-                    <a:p>
-                      <a:pPr algn="ctr"/>
-                      <a:r>
-                        <a:rPr sz="800" b="0">
-                          <a:solidFill>
-                            <a:srgbClr val="B06000"/>
-                          </a:solidFill>
-                        </a:rPr>
-                        <a:t>Neutre</a:t>
-                      </a:r>
-                    </a:p>
-                  </a:txBody>
-                  <a:tcPr>
-                    <a:solidFill>
-                      <a:srgbClr val="FDF3E5"/>
-                    </a:solidFill>
-                  </a:tcPr>
-                </a:tc>
-                <a:tc>
-                  <a:txBody>
-                    <a:bodyPr/>
-                    <a:lstStyle/>
-                    <a:p>
-                      <a:pPr algn="ctr"/>
-                      <a:r>
-                        <a:rPr sz="800" b="0">
-                          <a:solidFill>
-                            <a:srgbClr val="1A1A1A"/>
-                          </a:solidFill>
-                        </a:rPr>
-                        <a:t>10.9x</a:t>
-                      </a:r>
-                    </a:p>
-                  </a:txBody>
-                  <a:tcPr>
-                    <a:solidFill>
-                      <a:srgbClr val="F5F7FA"/>
-                    </a:solidFill>
-                  </a:tcPr>
-                </a:tc>
-                <a:tc>
-                  <a:txBody>
-                    <a:bodyPr/>
-                    <a:lstStyle/>
-                    <a:p>
-                      <a:pPr algn="ctr"/>
-                      <a:r>
-                        <a:rPr sz="800" b="0">
-                          <a:solidFill>
-                            <a:srgbClr val="1A1A1A"/>
-                          </a:solidFill>
-                        </a:rPr>
-                        <a:t>14.1%</a:t>
-                      </a:r>
-                    </a:p>
-                  </a:txBody>
-                  <a:tcPr>
-                    <a:solidFill>
-                      <a:srgbClr val="F5F7FA"/>
-                    </a:solidFill>
-                  </a:tcPr>
-                </a:tc>
-                <a:tc>
-                  <a:txBody>
-                    <a:bodyPr/>
-                    <a:lstStyle/>
-                    <a:p>
-                      <a:pPr algn="ctr"/>
-                      <a:r>
-                        <a:rPr sz="800" b="0">
-                          <a:solidFill>
-                            <a:srgbClr val="1A1A1A"/>
-                          </a:solidFill>
-                        </a:rPr>
-                        <a:t>-5.3%</a:t>
-                      </a:r>
-                    </a:p>
-                  </a:txBody>
-                  <a:tcPr>
-                    <a:solidFill>
-                      <a:srgbClr val="F5F7FA"/>
-                    </a:solidFill>
-                  </a:tcPr>
-                </a:tc>
-              </a:tr>
-              <a:tr h="255272">
-                <a:tc>
-                  <a:txBody>
-                    <a:bodyPr/>
-                    <a:lstStyle/>
-                    <a:p>
-                      <a:pPr algn="ctr"/>
-                      <a:r>
-                        <a:rPr sz="800" b="0">
-                          <a:solidFill>
-                            <a:srgbClr val="1A1A1A"/>
-                          </a:solidFill>
-                        </a:rPr>
-                        <a:t>7</a:t>
-                      </a:r>
-                    </a:p>
-                  </a:txBody>
-                  <a:tcPr>
-                    <a:noFill/>
-                  </a:tcPr>
-                </a:tc>
-                <a:tc>
-                  <a:txBody>
-                    <a:bodyPr/>
-                    <a:lstStyle/>
-                    <a:p>
-                      <a:pPr algn="ctr"/>
-                      <a:r>
-                        <a:rPr sz="800" b="0">
-                          <a:solidFill>
-                            <a:srgbClr val="1A1A1A"/>
-                          </a:solidFill>
-                        </a:rPr>
-                        <a:t>Comm. Services</a:t>
-                      </a:r>
-                    </a:p>
-                  </a:txBody>
-                  <a:tcPr>
-                    <a:noFill/>
-                  </a:tcPr>
-                </a:tc>
-                <a:tc>
-                  <a:txBody>
-                    <a:bodyPr/>
-                    <a:lstStyle/>
-                    <a:p>
-                      <a:pPr algn="ctr"/>
-                      <a:r>
-                        <a:rPr sz="800" b="0">
-                          <a:solidFill>
-                            <a:srgbClr val="1A1A1A"/>
-                          </a:solidFill>
-                        </a:rPr>
-                        <a:t>43</a:t>
-                      </a:r>
-                    </a:p>
-                  </a:txBody>
-                  <a:tcPr>
-                    <a:noFill/>
-                  </a:tcPr>
-                </a:tc>
-                <a:tc>
-                  <a:txBody>
-                    <a:bodyPr/>
-                    <a:lstStyle/>
-                    <a:p>
-                      <a:pPr algn="ctr"/>
-                      <a:r>
-                        <a:rPr sz="800" b="0">
-                          <a:solidFill>
-                            <a:srgbClr val="B06000"/>
-                          </a:solidFill>
-                        </a:rPr>
-                        <a:t>Neutre</a:t>
-                      </a:r>
-                    </a:p>
-                  </a:txBody>
-                  <a:tcPr>
-                    <a:solidFill>
-                      <a:srgbClr val="FDF3E5"/>
-                    </a:solidFill>
-                  </a:tcPr>
-                </a:tc>
-                <a:tc>
-                  <a:txBody>
-                    <a:bodyPr/>
-                    <a:lstStyle/>
-                    <a:p>
-                      <a:pPr algn="ctr"/>
-                      <a:r>
-                        <a:rPr sz="800" b="0">
-                          <a:solidFill>
-                            <a:srgbClr val="1A1A1A"/>
-                          </a:solidFill>
-                        </a:rPr>
-                        <a:t>7.7x</a:t>
-                      </a:r>
-                    </a:p>
-                  </a:txBody>
-                  <a:tcPr>
-                    <a:noFill/>
-                  </a:tcPr>
-                </a:tc>
-                <a:tc>
-                  <a:txBody>
-                    <a:bodyPr/>
-                    <a:lstStyle/>
-                    <a:p>
-                      <a:pPr algn="ctr"/>
-                      <a:r>
-                        <a:rPr sz="800" b="0">
-                          <a:solidFill>
-                            <a:srgbClr val="1A1A1A"/>
-                          </a:solidFill>
-                        </a:rPr>
-                        <a:t>34.5%</a:t>
-                      </a:r>
-                    </a:p>
-                  </a:txBody>
-                  <a:tcPr>
-                    <a:noFill/>
-                  </a:tcPr>
-                </a:tc>
-                <a:tc>
-                  <a:txBody>
-                    <a:bodyPr/>
-                    <a:lstStyle/>
-                    <a:p>
-                      <a:pPr algn="ctr"/>
-                      <a:r>
-                        <a:rPr sz="800" b="0">
-                          <a:solidFill>
-                            <a:srgbClr val="1A1A1A"/>
-                          </a:solidFill>
-                        </a:rPr>
-                        <a:t>+2.5%</a:t>
-                      </a:r>
-                    </a:p>
-                  </a:txBody>
-                  <a:tcPr>
-                    <a:noFill/>
-                  </a:tcPr>
-                </a:tc>
-              </a:tr>
-              <a:tr h="255272">
-                <a:tc>
-                  <a:txBody>
-                    <a:bodyPr/>
-                    <a:lstStyle/>
-                    <a:p>
-                      <a:pPr algn="ctr"/>
-                      <a:r>
-                        <a:rPr sz="800" b="0">
-                          <a:solidFill>
-                            <a:srgbClr val="1A1A1A"/>
-                          </a:solidFill>
-                        </a:rPr>
-                        <a:t>8</a:t>
-                      </a:r>
-                    </a:p>
-                  </a:txBody>
-                  <a:tcPr>
-                    <a:solidFill>
-                      <a:srgbClr val="F5F7FA"/>
-                    </a:solidFill>
-                  </a:tcPr>
-                </a:tc>
-                <a:tc>
-                  <a:txBody>
-                    <a:bodyPr/>
-                    <a:lstStyle/>
-                    <a:p>
-                      <a:pPr algn="ctr"/>
-                      <a:r>
-                        <a:rPr sz="800" b="0">
-                          <a:solidFill>
-                            <a:srgbClr val="1A1A1A"/>
-                          </a:solidFill>
-                        </a:rPr>
-                        <a:t>Cons. Discret.</a:t>
-                      </a:r>
-                    </a:p>
-                  </a:txBody>
-                  <a:tcPr>
-                    <a:solidFill>
-                      <a:srgbClr val="F5F7FA"/>
-                    </a:solidFill>
-                  </a:tcPr>
-                </a:tc>
-                <a:tc>
-                  <a:txBody>
-                    <a:bodyPr/>
-                    <a:lstStyle/>
-                    <a:p>
-                      <a:pPr algn="ctr"/>
-                      <a:r>
-                        <a:rPr sz="800" b="0">
-                          <a:solidFill>
-                            <a:srgbClr val="1A1A1A"/>
-                          </a:solidFill>
-                        </a:rPr>
-                        <a:t>39</a:t>
-                      </a:r>
-                    </a:p>
-                  </a:txBody>
-                  <a:tcPr>
-                    <a:solidFill>
-                      <a:srgbClr val="F5F7FA"/>
-                    </a:solidFill>
-                  </a:tcPr>
-                </a:tc>
-                <a:tc>
-                  <a:txBody>
-                    <a:bodyPr/>
-                    <a:lstStyle/>
-                    <a:p>
-                      <a:pPr algn="ctr"/>
-                      <a:r>
-                        <a:rPr sz="800" b="0">
-                          <a:solidFill>
-                            <a:srgbClr val="A82020"/>
-                          </a:solidFill>
-                        </a:rPr>
-                        <a:t>Sous-ponderer</a:t>
-                      </a:r>
-                    </a:p>
-                  </a:txBody>
-                  <a:tcPr>
-                    <a:solidFill>
-                      <a:srgbClr val="FBEBEB"/>
-                    </a:solidFill>
-                  </a:tcPr>
-                </a:tc>
-                <a:tc>
-                  <a:txBody>
-                    <a:bodyPr/>
-                    <a:lstStyle/>
-                    <a:p>
-                      <a:pPr algn="ctr"/>
-                      <a:r>
-                        <a:rPr sz="800" b="0">
-                          <a:solidFill>
-                            <a:srgbClr val="1A1A1A"/>
-                          </a:solidFill>
-                        </a:rPr>
-                        <a:t>10.9x</a:t>
-                      </a:r>
-                    </a:p>
-                  </a:txBody>
-                  <a:tcPr>
-                    <a:solidFill>
-                      <a:srgbClr val="F5F7FA"/>
-                    </a:solidFill>
-                  </a:tcPr>
-                </a:tc>
-                <a:tc>
-                  <a:txBody>
-                    <a:bodyPr/>
-                    <a:lstStyle/>
-                    <a:p>
-                      <a:pPr algn="ctr"/>
-                      <a:r>
-                        <a:rPr sz="800" b="0">
-                          <a:solidFill>
-                            <a:srgbClr val="1A1A1A"/>
-                          </a:solidFill>
-                        </a:rPr>
-                        <a:t>7.3%</a:t>
-                      </a:r>
-                    </a:p>
-                  </a:txBody>
-                  <a:tcPr>
-                    <a:solidFill>
-                      <a:srgbClr val="F5F7FA"/>
-                    </a:solidFill>
-                  </a:tcPr>
-                </a:tc>
-                <a:tc>
-                  <a:txBody>
-                    <a:bodyPr/>
-                    <a:lstStyle/>
-                    <a:p>
-                      <a:pPr algn="ctr"/>
-                      <a:r>
-                        <a:rPr sz="800" b="0">
-                          <a:solidFill>
-                            <a:srgbClr val="1A1A1A"/>
-                          </a:solidFill>
-                        </a:rPr>
-                        <a:t>-1.4%</a:t>
-                      </a:r>
-                    </a:p>
-                  </a:txBody>
-                  <a:tcPr>
-                    <a:solidFill>
-                      <a:srgbClr val="F5F7FA"/>
-                    </a:solidFill>
-                  </a:tcPr>
-                </a:tc>
-              </a:tr>
-              <a:tr h="255272">
-                <a:tc>
-                  <a:txBody>
-                    <a:bodyPr/>
-                    <a:lstStyle/>
-                    <a:p>
-                      <a:pPr algn="ctr"/>
-                      <a:r>
-                        <a:rPr sz="800" b="0">
-                          <a:solidFill>
-                            <a:srgbClr val="1A1A1A"/>
-                          </a:solidFill>
-                        </a:rPr>
-                        <a:t>9</a:t>
-                      </a:r>
-                    </a:p>
-                  </a:txBody>
-                  <a:tcPr>
-                    <a:noFill/>
-                  </a:tcPr>
-                </a:tc>
-                <a:tc>
-                  <a:txBody>
-                    <a:bodyPr/>
-                    <a:lstStyle/>
-                    <a:p>
-                      <a:pPr algn="ctr"/>
-                      <a:r>
-                        <a:rPr sz="800" b="0">
-                          <a:solidFill>
-                            <a:srgbClr val="1A1A1A"/>
-                          </a:solidFill>
-                        </a:rPr>
-                        <a:t>Cons. Staples</a:t>
-                      </a:r>
-                    </a:p>
-                  </a:txBody>
-                  <a:tcPr>
-                    <a:noFill/>
-                  </a:tcPr>
-                </a:tc>
-                <a:tc>
-                  <a:txBody>
-                    <a:bodyPr/>
-                    <a:lstStyle/>
-                    <a:p>
-                      <a:pPr algn="ctr"/>
-                      <a:r>
-                        <a:rPr sz="800" b="0">
-                          <a:solidFill>
-                            <a:srgbClr val="1A1A1A"/>
-                          </a:solidFill>
-                        </a:rPr>
-                        <a:t>32</a:t>
-                      </a:r>
-                    </a:p>
-                  </a:txBody>
-                  <a:tcPr>
-                    <a:noFill/>
-                  </a:tcPr>
-                </a:tc>
-                <a:tc>
-                  <a:txBody>
-                    <a:bodyPr/>
-                    <a:lstStyle/>
-                    <a:p>
-                      <a:pPr algn="ctr"/>
-                      <a:r>
-                        <a:rPr sz="800" b="0">
-                          <a:solidFill>
-                            <a:srgbClr val="A82020"/>
-                          </a:solidFill>
-                        </a:rPr>
-                        <a:t>Sous-ponderer</a:t>
-                      </a:r>
-                    </a:p>
-                  </a:txBody>
-                  <a:tcPr>
-                    <a:solidFill>
-                      <a:srgbClr val="FBEBEB"/>
-                    </a:solidFill>
-                  </a:tcPr>
-                </a:tc>
-                <a:tc>
-                  <a:txBody>
-                    <a:bodyPr/>
-                    <a:lstStyle/>
-                    <a:p>
-                      <a:pPr algn="ctr"/>
-                      <a:r>
-                        <a:rPr sz="800" b="0">
-                          <a:solidFill>
-                            <a:srgbClr val="1A1A1A"/>
-                          </a:solidFill>
-                        </a:rPr>
-                        <a:t>8.7x</a:t>
-                      </a:r>
-                    </a:p>
-                  </a:txBody>
-                  <a:tcPr>
-                    <a:noFill/>
-                  </a:tcPr>
-                </a:tc>
-                <a:tc>
-                  <a:txBody>
-                    <a:bodyPr/>
-                    <a:lstStyle/>
-                    <a:p>
-                      <a:pPr algn="ctr"/>
-                      <a:r>
-                        <a:rPr sz="800" b="0">
-                          <a:solidFill>
-                            <a:srgbClr val="1A1A1A"/>
-                          </a:solidFill>
-                        </a:rPr>
-                        <a:t>16.0%</a:t>
-                      </a:r>
-                    </a:p>
-                  </a:txBody>
-                  <a:tcPr>
-                    <a:noFill/>
-                  </a:tcPr>
-                </a:tc>
-                <a:tc>
-                  <a:txBody>
-                    <a:bodyPr/>
-                    <a:lstStyle/>
-                    <a:p>
-                      <a:pPr algn="ctr"/>
-                      <a:r>
-                        <a:rPr sz="800" b="0">
-                          <a:solidFill>
-                            <a:srgbClr val="1A1A1A"/>
-                          </a:solidFill>
-                        </a:rPr>
-                        <a:t>-3.2%</a:t>
-                      </a:r>
-                    </a:p>
-                  </a:txBody>
-                  <a:tcPr>
-                    <a:noFill/>
-                  </a:tcPr>
-                </a:tc>
-              </a:tr>
-              <a:tr h="255280">
-                <a:tc>
-                  <a:txBody>
-                    <a:bodyPr/>
-                    <a:lstStyle/>
-                    <a:p>
-                      <a:pPr algn="ctr"/>
-                      <a:r>
-                        <a:rPr sz="800" b="0">
-                          <a:solidFill>
-                            <a:srgbClr val="1A1A1A"/>
-                          </a:solidFill>
-                        </a:rPr>
-                        <a:t>10</a:t>
-                      </a:r>
-                    </a:p>
-                  </a:txBody>
-                  <a:tcPr>
-                    <a:solidFill>
-                      <a:srgbClr val="F5F7FA"/>
-                    </a:solidFill>
-                  </a:tcPr>
-                </a:tc>
-                <a:tc>
-                  <a:txBody>
-                    <a:bodyPr/>
-                    <a:lstStyle/>
-                    <a:p>
-                      <a:pPr algn="ctr"/>
-                      <a:r>
-                        <a:rPr sz="800" b="0">
-                          <a:solidFill>
-                            <a:srgbClr val="1A1A1A"/>
-                          </a:solidFill>
-                        </a:rPr>
-                        <a:t>Real Estate</a:t>
-                      </a:r>
-                    </a:p>
-                  </a:txBody>
-                  <a:tcPr>
-                    <a:solidFill>
-                      <a:srgbClr val="F5F7FA"/>
-                    </a:solidFill>
-                  </a:tcPr>
-                </a:tc>
-                <a:tc>
-                  <a:txBody>
-                    <a:bodyPr/>
-                    <a:lstStyle/>
-                    <a:p>
-                      <a:pPr algn="ctr"/>
-                      <a:r>
-                        <a:rPr sz="800" b="0">
-                          <a:solidFill>
-                            <a:srgbClr val="1A1A1A"/>
-                          </a:solidFill>
-                        </a:rPr>
-                        <a:t>27</a:t>
-                      </a:r>
-                    </a:p>
-                  </a:txBody>
-                  <a:tcPr>
-                    <a:solidFill>
-                      <a:srgbClr val="F5F7FA"/>
-                    </a:solidFill>
-                  </a:tcPr>
-                </a:tc>
-                <a:tc>
-                  <a:txBody>
-                    <a:bodyPr/>
-                    <a:lstStyle/>
-                    <a:p>
-                      <a:pPr algn="ctr"/>
-                      <a:r>
-                        <a:rPr sz="800" b="0">
-                          <a:solidFill>
-                            <a:srgbClr val="A82020"/>
-                          </a:solidFill>
-                        </a:rPr>
-                        <a:t>Sous-ponderer</a:t>
-                      </a:r>
-                    </a:p>
-                  </a:txBody>
-                  <a:tcPr>
-                    <a:solidFill>
-                      <a:srgbClr val="FBEBEB"/>
-                    </a:solidFill>
-                  </a:tcPr>
-                </a:tc>
-                <a:tc>
-                  <a:txBody>
-                    <a:bodyPr/>
-                    <a:lstStyle/>
-                    <a:p>
-                      <a:pPr algn="ctr"/>
-                      <a:r>
-                        <a:rPr sz="800" b="0">
-                          <a:solidFill>
-                            <a:srgbClr val="1A1A1A"/>
-                          </a:solidFill>
-                        </a:rPr>
-                        <a:t>28.4x</a:t>
-                      </a:r>
-                    </a:p>
-                  </a:txBody>
-                  <a:tcPr>
-                    <a:solidFill>
-                      <a:srgbClr val="F5F7FA"/>
-                    </a:solidFill>
-                  </a:tcPr>
-                </a:tc>
-                <a:tc>
-                  <a:txBody>
-                    <a:bodyPr/>
-                    <a:lstStyle/>
-                    <a:p>
-                      <a:pPr algn="ctr"/>
-                      <a:r>
-                        <a:rPr sz="800" b="0">
-                          <a:solidFill>
-                            <a:srgbClr val="1A1A1A"/>
-                          </a:solidFill>
-                        </a:rPr>
-                        <a:t>33.6%</a:t>
-                      </a:r>
-                    </a:p>
-                  </a:txBody>
-                  <a:tcPr>
-                    <a:solidFill>
-                      <a:srgbClr val="F5F7FA"/>
-                    </a:solidFill>
-                  </a:tcPr>
-                </a:tc>
-                <a:tc>
-                  <a:txBody>
-                    <a:bodyPr/>
-                    <a:lstStyle/>
-                    <a:p>
-                      <a:pPr algn="ctr"/>
-                      <a:r>
-                        <a:rPr sz="800" b="0">
-                          <a:solidFill>
-                            <a:srgbClr val="1A1A1A"/>
-                          </a:solidFill>
-                        </a:rPr>
-                        <a:t>-35.9%</a:t>
-                      </a:r>
-                    </a:p>
-                  </a:txBody>
-                  <a:tcPr>
-                    <a:solidFill>
-                      <a:srgbClr val="F5F7FA"/>
-                    </a:solidFill>
-                  </a:tcPr>
-                </a:tc>
-              </a:tr>
-            </a:tbl>
-          </a:graphicData>
-        </a:graphic>
-      </p:graphicFrame>
-      <p:sp>
-        <p:nvSpPr>
-          <p:cNvPr id="30" name="Rectangle 29"/>
-          <p:cNvSpPr/>
-          <p:nvPr/>
-        </p:nvSpPr>
-        <p:spPr>
-          <a:xfrm>
-            <a:off x="324000" y="4248000"/>
-            <a:ext cx="8496000" cy="540000"/>
+            <a:off x="0" y="4950000"/>
+            <a:ext cx="9144000" cy="180000"/>
           </a:xfrm>
           <a:prstGeom prst="rect">
             <a:avLst/>
@@ -21796,161 +19757,7 @@
       </p:sp>
       <p:sp>
         <p:nvSpPr>
-          <p:cNvPr id="31" name="Rectangle 30"/>
-          <p:cNvSpPr/>
-          <p:nvPr/>
-        </p:nvSpPr>
-        <p:spPr>
-          <a:xfrm>
-            <a:off x="324000" y="4248000"/>
-            <a:ext cx="43200" cy="540000"/>
-          </a:xfrm>
-          <a:prstGeom prst="rect">
-            <a:avLst/>
-          </a:prstGeom>
-          <a:solidFill>
-            <a:srgbClr val="AAAAAA"/>
-          </a:solidFill>
-          <a:ln>
-            <a:noFill/>
-          </a:ln>
-        </p:spPr>
-        <p:style>
-          <a:lnRef idx="1">
-            <a:schemeClr val="accent1"/>
-          </a:lnRef>
-          <a:fillRef idx="3">
-            <a:schemeClr val="accent1"/>
-          </a:fillRef>
-          <a:effectRef idx="2">
-            <a:schemeClr val="accent1"/>
-          </a:effectRef>
-          <a:fontRef idx="minor">
-            <a:schemeClr val="lt1"/>
-          </a:fontRef>
-        </p:style>
-        <p:txBody>
-          <a:bodyPr rtlCol="0" anchor="ctr"/>
-          <a:lstStyle/>
-          <a:p>
-            <a:pPr algn="ctr"/>
-          </a:p>
-        </p:txBody>
-      </p:sp>
-      <p:sp>
-        <p:nvSpPr>
-          <p:cNvPr id="32" name="TextBox 31"/>
-          <p:cNvSpPr txBox="1"/>
-          <p:nvPr/>
-        </p:nvSpPr>
-        <p:spPr>
-          <a:xfrm>
-            <a:off x="432000" y="4284000"/>
-            <a:ext cx="8208000" cy="180000"/>
-          </a:xfrm>
-          <a:prstGeom prst="rect">
-            <a:avLst/>
-          </a:prstGeom>
-          <a:noFill/>
-        </p:spPr>
-        <p:txBody>
-          <a:bodyPr wrap="square">
-            <a:spAutoFit/>
-          </a:bodyPr>
-          <a:lstStyle/>
-          <a:p>
-            <a:pPr algn="l"/>
-            <a:r>
-              <a:rPr sz="800" b="1" i="0">
-                <a:solidFill>
-                  <a:srgbClr val="555555"/>
-                </a:solidFill>
-              </a:rPr>
-              <a:t>Note — ETF sectoriels SPDR non disponibles pour cet indice</a:t>
-            </a:r>
-          </a:p>
-        </p:txBody>
-      </p:sp>
-      <p:sp>
-        <p:nvSpPr>
-          <p:cNvPr id="33" name="TextBox 32"/>
-          <p:cNvSpPr txBox="1"/>
-          <p:nvPr/>
-        </p:nvSpPr>
-        <p:spPr>
-          <a:xfrm>
-            <a:off x="432000" y="4482000"/>
-            <a:ext cx="8208000" cy="288000"/>
-          </a:xfrm>
-          <a:prstGeom prst="rect">
-            <a:avLst/>
-          </a:prstGeom>
-          <a:noFill/>
-        </p:spPr>
-        <p:txBody>
-          <a:bodyPr wrap="square">
-            <a:spAutoFit/>
-          </a:bodyPr>
-          <a:lstStyle/>
-          <a:p>
-            <a:pPr algn="l"/>
-            <a:r>
-              <a:rPr sz="750" b="0" i="0">
-                <a:solidFill>
-                  <a:srgbClr val="555555"/>
-                </a:solidFill>
-              </a:rPr>
-              <a:t>Les ETF sectoriels SPDR sont references sur le marche US (S&amp;P 500). Pour les indices europeens, les equivalents iShares / Amundi ne sont pas encore integres.</a:t>
-            </a:r>
-          </a:p>
-        </p:txBody>
-      </p:sp>
-      <p:sp>
-        <p:nvSpPr>
-          <p:cNvPr id="34" name="Rectangle 33"/>
-          <p:cNvSpPr/>
-          <p:nvPr/>
-        </p:nvSpPr>
-        <p:spPr>
-          <a:xfrm>
-            <a:off x="0" y="4950000"/>
-            <a:ext cx="9144000" cy="180000"/>
-          </a:xfrm>
-          <a:prstGeom prst="rect">
-            <a:avLst/>
-          </a:prstGeom>
-          <a:solidFill>
-            <a:srgbClr val="F5F7FA"/>
-          </a:solidFill>
-          <a:ln>
-            <a:noFill/>
-          </a:ln>
-        </p:spPr>
-        <p:style>
-          <a:lnRef idx="1">
-            <a:schemeClr val="accent1"/>
-          </a:lnRef>
-          <a:fillRef idx="3">
-            <a:schemeClr val="accent1"/>
-          </a:fillRef>
-          <a:effectRef idx="2">
-            <a:schemeClr val="accent1"/>
-          </a:effectRef>
-          <a:fontRef idx="minor">
-            <a:schemeClr val="lt1"/>
-          </a:fontRef>
-        </p:style>
-        <p:txBody>
-          <a:bodyPr rtlCol="0" anchor="ctr"/>
-          <a:lstStyle/>
-          <a:p>
-            <a:pPr algn="ctr"/>
-          </a:p>
-        </p:txBody>
-      </p:sp>
-      <p:sp>
-        <p:nvSpPr>
-          <p:cNvPr id="35" name="TextBox 34"/>
+          <p:cNvPr id="21" name="TextBox 20"/>
           <p:cNvSpPr txBox="1"/>
           <p:nvPr/>
         </p:nvSpPr>

</xml_diff>